<commit_message>
Update slides for the deployed node type and the account limits
Co-Authored-By: Claude Opus 5.5 <noreply@anthropic.com>
Claude-Session: https://claude.ai/code/session_01MkuxqrkVQWnB51GmsWtWHR
</commit_message>
<xml_diff>
--- a/demo/presentation.pptx
+++ b/demo/presentation.pptx
@@ -118,29 +118,29 @@
   <p:extLst>
     <p:ext uri="{521415D9-36F7-43E2-AB2F-B90AF26B5E84}">
       <p14:sectionLst xmlns:p14="http://schemas.microsoft.com/office/powerpoint/2010/main">
-        <p14:section name="Intro" id="{40822627-e8c4-b181-58bf-209312f1a3d4}">
+        <p14:section name="Intro" id="{4ff9149d-fe62-72b7-b236-fb20a1a6cdbb}">
           <p14:sldIdLst>
             <p14:sldId id="256"/>
           </p14:sldIdLst>
         </p14:section>
-        <p14:section name="Project" id="{95525893-2186-9599-3a6e-fc8f1b0bef2d}">
+        <p14:section name="Project" id="{bb24f38e-717e-a79e-2401-ccc617aac469}">
           <p14:sldIdLst>
             <p14:sldId id="257"/>
             <p14:sldId id="258"/>
           </p14:sldIdLst>
         </p14:section>
-        <p14:section name="Architecture" id="{f4ea7b82-e79e-130a-cebe-16c7cba3ac00}">
+        <p14:section name="Architecture" id="{6f3fd6ed-0d75-096d-a79f-aa9b895da130}">
           <p14:sldIdLst>
             <p14:sldId id="259"/>
           </p14:sldIdLst>
         </p14:section>
-        <p14:section name="Delivery" id="{9e305325-c9b8-13f6-a911-b17a5c918f06}">
+        <p14:section name="Delivery" id="{7c24b69c-1142-5058-f8d5-9515c4e800b7}">
           <p14:sldIdLst>
             <p14:sldId id="260"/>
             <p14:sldId id="261"/>
           </p14:sldIdLst>
         </p14:section>
-        <p14:section name="Platform" id="{283b2e73-85c2-9fe4-5671-de86ca936070}">
+        <p14:section name="Platform" id="{4bc88766-2345-ed2e-371e-ce640643a1aa}">
           <p14:sldIdLst>
             <p14:sldId id="262"/>
             <p14:sldId id="263"/>
@@ -148,7 +148,7 @@
             <p14:sldId id="265"/>
           </p14:sldIdLst>
         </p14:section>
-        <p14:section name="Close" id="{91553871-f77c-73d8-42be-89d86d690d9b}">
+        <p14:section name="Close" id="{e4f589da-6826-5584-2a3f-782ed5258dda}">
           <p14:sldIdLst>
             <p14:sldId id="266"/>
             <p14:sldId id="267"/>
@@ -3324,7 +3324,7 @@
                 <a:ea typeface="Calibri" pitchFamily="34" charset="-122"/>
                 <a:cs typeface="Calibri" pitchFamily="34" charset="-120"/>
               </a:rPr>
-              <a:t>An SCP denied every region except ap-southeast-2; checking with dry-run calls saved a failed apply.</a:t>
+              <a:t>The org SCP allows only ap-southeast-2 and blocks OIDC providers; the Free plan rejects t3.medium, so nodes run m7i-flex.large.</a:t>
             </a:r>
             <a:endParaRPr lang="en-US" sz="1200" dirty="0"/>
           </a:p>
@@ -5539,7 +5539,7 @@
                 <a:ea typeface="Calibri" pitchFamily="34" charset="-122"/>
                 <a:cs typeface="Calibri" pitchFamily="34" charset="-120"/>
               </a:rPr>
-              <a:t>EKS cluster · ap-southeast-2 · 3 × t3.medium in private subnets</a:t>
+              <a:t>EKS cluster · ap-southeast-2 · 2 × m7i-flex.large in private subnets</a:t>
             </a:r>
             <a:endParaRPr lang="en-US" sz="1200" dirty="0"/>
           </a:p>
@@ -8817,7 +8817,7 @@
                 <a:ea typeface="Calibri" pitchFamily="34" charset="-122"/>
                 <a:cs typeface="Calibri" pitchFamily="34" charset="-120"/>
               </a:rPr>
-              <a:t>EKS nodes (t3.medium)</a:t>
+              <a:t>EKS node (m7i-flex.large)</a:t>
             </a:r>
             <a:endParaRPr lang="en-US" sz="1200" dirty="0"/>
           </a:p>
@@ -9022,7 +9022,7 @@
                 <a:ea typeface="Calibri" pitchFamily="34" charset="-122"/>
                 <a:cs typeface="Calibri" pitchFamily="34" charset="-120"/>
               </a:rPr>
-              <a:t>EKS nodes (t3.medium)</a:t>
+              <a:t>EKS node (m7i-flex.large)</a:t>
             </a:r>
             <a:endParaRPr lang="en-US" sz="1200" dirty="0"/>
           </a:p>
@@ -9235,7 +9235,7 @@
                 <a:ea typeface="Calibri" pitchFamily="34" charset="-122"/>
                 <a:cs typeface="Calibri" pitchFamily="34" charset="-120"/>
               </a:rPr>
-              <a:t>About $0.35/hour while up; destroyed after the demo</a:t>
+              <a:t>About $0.40/hour while up; destroyed after the demo</a:t>
             </a:r>
             <a:endParaRPr lang="en-US" sz="1300" dirty="0"/>
           </a:p>

</xml_diff>